<commit_message>
docs: update slide-by-slide presentation speech with terminology explanations
</commit_message>
<xml_diff>
--- a/assignment2_3/template_ppt/question2_3_template.pptx
+++ b/assignment2_3/template_ppt/question2_3_template.pptx
@@ -686,7 +686,35 @@
           <a:lstStyle/>
           <a:p>
             <a:r>
-              <a:t>【接在小组第二题第（2）问后】我负责第三小问：在线性控制房间数以后，土地面积与房屋总价值之间有什么关系。这里用全样本，五间房样本是下一小问的内容。本页沿用组员模板的分节样式，不重复整组封面。</a:t>
+              <a:t>第1页｜土地面积与房屋总价值</a:t>
+            </a:r>
+          </a:p>
+          <a:p/>
+          <a:p>
+            <a:r>
+              <a:t>【操作提示】</a:t>
+            </a:r>
+          </a:p>
+          <a:p>
+            <a:r>
+              <a:t>展示第1页。开场后翻到第2页。</a:t>
+            </a:r>
+          </a:p>
+          <a:p/>
+          <a:p>
+            <a:r>
+              <a:t>【上台讲稿】</a:t>
+            </a:r>
+          </a:p>
+          <a:p>
+            <a:r>
+              <a:t>大家好，我负责第二题的第三小问。这一问研究的是：在线性控制房间数以后，土地面积与房屋总价值之间有什么关系。</a:t>
+            </a:r>
+          </a:p>
+          <a:p/>
+          <a:p>
+            <a:r>
+              <a:t>我会先说明题目和分析方法，再用老师提供的代码现场运行，最后比较两种设定下的结果。</a:t>
             </a:r>
           </a:p>
         </p:txBody>
@@ -756,7 +784,47 @@
           <a:lstStyle/>
           <a:p>
             <a:r>
-              <a:t>【先讲人话】老师让我们比较两种方法画出的关系。大地块房子也可能有更多房间，所以要把房间数一起考虑。土地面积是地块面积，不是室内面积；总价值按数据原单位解释，不擅自称为成交价。</a:t>
+              <a:t>第2页｜这一问要我们做什么？</a:t>
+            </a:r>
+          </a:p>
+          <a:p/>
+          <a:p>
+            <a:r>
+              <a:t>【操作提示】</a:t>
+            </a:r>
+          </a:p>
+          <a:p>
+            <a:r>
+              <a:t>指向页面上的三个变量，再指向下方的样本量。</a:t>
+            </a:r>
+          </a:p>
+          <a:p/>
+          <a:p>
+            <a:r>
+              <a:t>【上台讲稿】</a:t>
+            </a:r>
+          </a:p>
+          <a:p>
+            <a:r>
+              <a:t>这一问可以用一句话理解：把房间数的差异考虑进去以后，土地更大的房子，总价值通常也更高吗？</a:t>
+            </a:r>
+          </a:p>
+          <a:p/>
+          <a:p>
+            <a:r>
+              <a:t>我们关注三个变量。第一个是 total_value，也就是房屋总价值；第二个是 lot_size_acres，也就是土地面积，单位是英亩。这里是地块面积，不是室内面积。第三个是 n_rooms，也就是房间数。</a:t>
+            </a:r>
+          </a:p>
+          <a:p/>
+          <a:p>
+            <a:r>
+              <a:t>为什么要考虑房间数？因为土地较大的房子，也可能有更多房间。如果不把房间数放进模型，就不容易区分这些差异。因此，本题把房间数作为线性控制变量加入回归。</a:t>
+            </a:r>
+          </a:p>
+          <a:p/>
+          <a:p>
+            <a:r>
+              <a:t>这里的“线性控制”，是用一个由数据估计的固定系数乘上房间数，放进模型。它不是只挑同样房间数的房子。本问使用全部十万条记录，没有限制为五间房。</a:t>
             </a:r>
           </a:p>
         </p:txBody>
@@ -826,7 +894,59 @@
           <a:lstStyle/>
           <a:p>
             <a:r>
-              <a:t>【解释分箱】箱就是土地面积区间。软件把土地面积划成若干区间，本次两次都选出27箱。第一种箱内常数，第二种是二次样条。第二个数字2表示连接处函数值和一阶导数连续，通俗说就是高度和倾斜程度平滑衔接。两个2不是两个箱。</a:t>
+              <a:t>第3页｜两种方法：同一批房子，不同的拟合方式</a:t>
+            </a:r>
+          </a:p>
+          <a:p/>
+          <a:p>
+            <a:r>
+              <a:t>【操作提示】</a:t>
+            </a:r>
+          </a:p>
+          <a:p>
+            <a:r>
+              <a:t>先解释“箱”，然后分别指向左、右两种设定。页面下方的27是实际箱数。</a:t>
+            </a:r>
+          </a:p>
+          <a:p/>
+          <a:p>
+            <a:r>
+              <a:t>【上台讲稿】</a:t>
+            </a:r>
+          </a:p>
+          <a:p>
+            <a:r>
+              <a:t>这里先解释一个术语：binscatter，可以理解为分箱散点方法。我们把横轴上的土地面积划分成若干区间，每个区间就叫一个“箱”，再用代表性的拟合点展示关系。所以，一个蓝点不是一套房子。</a:t>
+            </a:r>
+          </a:p>
+          <a:p/>
+          <a:p>
+            <a:r>
+              <a:t>我们使用 R 的 binsreg 工具包来做这项分析，同时在线性回归中考虑房间数。binscatter 是方法名称，binsreg 是我们使用的工具包名称，里面的 binsreg 函数负责执行估计。</a:t>
+            </a:r>
+          </a:p>
+          <a:p/>
+          <a:p>
+            <a:r>
+              <a:t>老师要求比较两种拟合线。line 后面的两个数字，分别表示每段多项式的次数，以及连接处的平滑约束数量。</a:t>
+            </a:r>
+          </a:p>
+          <a:p/>
+          <a:p>
+            <a:r>
+              <a:t>左边是 line 等于 c 零零。第一个零表示每段是零次多项式，也就是常数；第二个零表示不要求连接处连续。通俗地说，每个箱内画水平线，箱与箱之间可以跳跃。</a:t>
+            </a:r>
+          </a:p>
+          <a:p/>
+          <a:p>
+            <a:r>
+              <a:t>右边是 line 等于 c 二二。第一个二表示每段可以用二次曲线；第二个二要求相邻区间的高度和斜率都接得上，也就是平滑连接。这叫二次样条。</a:t>
+            </a:r>
+          </a:p>
+          <a:p/>
+          <a:p>
+            <a:r>
+              <a:t>因此，两种设置的区别，是同一个箱里能不能表达弯曲变化。这两个数字不是分箱数量。本次两次分析都选出了二十七个箱。</a:t>
             </a:r>
           </a:p>
         </p:txBody>
@@ -896,7 +1016,88 @@
           <a:lstStyle/>
           <a:p>
             <a:r>
-              <a:t>【操作】切到RStudio，打开question2_3.R。先设置工作目录到脚本所在目录，再点Source，等Console重新出现&gt;。这页展示的是脚本核心调用，不是另写一套模型。左侧y是总价值，x是土地面积，w是房间数；drop=FALSE保留数据框结构。m1存第一组结果，m2存第二组。两次调用前均set.seed(407)，固定随机选择过程。老师代码中其他分箱参数保持默认。</a:t>
+              <a:t>第4页｜现场运行：沿用老师的 binsreg 代码</a:t>
+            </a:r>
+          </a:p>
+          <a:p/>
+          <a:p>
+            <a:r>
+              <a:t>【操作提示】</a:t>
+            </a:r>
+          </a:p>
+          <a:p>
+            <a:r>
+              <a:t>先在PPT指着y、x、w和line讲解，再按以下顺序操作：</a:t>
+            </a:r>
+          </a:p>
+          <a:p>
+            <a:r>
+              <a:t>1. Alt+Tab切换到RStudio，打开question2_3.R。</a:t>
+            </a:r>
+          </a:p>
+          <a:p>
+            <a:r>
+              <a:t>2. Session → Set Working Directory → To Source File Location。</a:t>
+            </a:r>
+          </a:p>
+          <a:p>
+            <a:r>
+              <a:t>3. 点击Source，等待Console重新出现 &gt;。不要运行install.R。</a:t>
+            </a:r>
+          </a:p>
+          <a:p>
+            <a:r>
+              <a:t>4. 在Console输入print(g1)，按回车，点Zoom；展示后关闭放大窗口。</a:t>
+            </a:r>
+          </a:p>
+          <a:p>
+            <a:r>
+              <a:t>5. 输入print(g2)，按回车，点Zoom；展示后关闭放大窗口。</a:t>
+            </a:r>
+          </a:p>
+          <a:p>
+            <a:r>
+              <a:t>6. Alt+Tab切回PPT，进入第5页。接下来用PPT里的图详细解释。</a:t>
+            </a:r>
+          </a:p>
+          <a:p>
+            <a:r>
+              <a:t>学校电脑上的软件与包必须在课前准备好。</a:t>
+            </a:r>
+          </a:p>
+          <a:p/>
+          <a:p>
+            <a:r>
+              <a:t>【上台讲稿】</a:t>
+            </a:r>
+          </a:p>
+          <a:p>
+            <a:r>
+              <a:t>这里展示的是老师提供的核心回归代码。y 指定房屋总价值，x 指定土地面积，w 指定房间数。两次回归的这三个变量完全相同，主要区别就是 line 的设定。</a:t>
+            </a:r>
+          </a:p>
+          <a:p/>
+          <a:p>
+            <a:r>
+              <a:t>第一组结果存为 m1，第二组存为 m2。每次调用前，我都设置相同随机种子，帮助重复比较。脚本后半部分给图加标题，并保存图片和模型摘要。</a:t>
+            </a:r>
+          </a:p>
+          <a:p/>
+          <a:p>
+            <a:r>
+              <a:t>现在我切换到 RStudio，现场重新运行整份脚本。</a:t>
+            </a:r>
+          </a:p>
+          <a:p/>
+          <a:p>
+            <a:r>
+              <a:t>【点击 Source 后等待，不需要一直说话。】</a:t>
+            </a:r>
+          </a:p>
+          <a:p/>
+          <a:p>
+            <a:r>
+              <a:t>程序运行完成，我分别显示两张刚生成的图。后面的PPT使用相同设定得到的图，方便大家看清细节。现在切回PPT，先看第一张。</a:t>
             </a:r>
           </a:p>
         </p:txBody>
@@ -966,7 +1167,47 @@
           <a:lstStyle/>
           <a:p>
             <a:r>
-              <a:t>【输入print(g1)，Zoom】横轴是土地面积，纵轴是调整房间数后的拟合总价值。蓝点不是单套房，而是分箱代表性拟合点。最后一箱1.5到4英亩，共3671条记录，拟合值约58.5万。它水平是因为箱内只能常数，不表示增加土地没有价值。横线不是置信区间。</a:t>
+              <a:t>第5页｜第一种结果：每个区间内是一条水平线</a:t>
+            </a:r>
+          </a:p>
+          <a:p/>
+          <a:p>
+            <a:r>
+              <a:t>【操作提示】</a:t>
+            </a:r>
+          </a:p>
+          <a:p>
+            <a:r>
+              <a:t>指横轴和纵轴，再指向右侧长横线。若有人问是否是置信区间，使用文末备用回答。</a:t>
+            </a:r>
+          </a:p>
+          <a:p/>
+          <a:p>
+            <a:r>
+              <a:t>【上台讲稿】</a:t>
+            </a:r>
+          </a:p>
+          <a:p>
+            <a:r>
+              <a:t>先看坐标。横轴往右，表示土地面积越来越大；纵轴往上，表示拟合的房屋总价值越高。模型已经把房间数纳入考虑，图形默认在样本平均房间数处展示拟合值，所以蓝点不能直接当作原始平均房价。</a:t>
+            </a:r>
+          </a:p>
+          <a:p/>
+          <a:p>
+            <a:r>
+              <a:t>第一种设定中，每个区间内的拟合值固定，箱与箱之间可以跳跃。左边有些区间比较窄，水平线很短，看起来就像只有一个点。</a:t>
+            </a:r>
+          </a:p>
+          <a:p/>
+          <a:p>
+            <a:r>
+              <a:t>右边这条长横线对应最后一个箱，覆盖一点五到四英亩。因为这个设定只允许箱内使用一个固定值，所以整段都是水平线。</a:t>
+            </a:r>
+          </a:p>
+          <a:p/>
+          <a:p>
+            <a:r>
+              <a:t>这不表示实际房屋价值完全一样，也不能解释成土地超过一点五英亩以后，继续增加就没有价值。水平线首先来自我们的拟合方式。</a:t>
             </a:r>
           </a:p>
         </p:txBody>
@@ -1036,7 +1277,41 @@
           <a:lstStyle/>
           <a:p>
             <a:r>
-              <a:t>【输入print(g2)，Zoom】二次样条在连接处平滑。小地块区域仍有波动，不能称为全程单调上升。约1英亩以后总体向上。接近4英亩的绘图网格拟合值约65万。图中未画置信区间，不判断每个局部变化是否显著。两张单图纵轴刻度不同，比较要看数值。</a:t>
+              <a:t>第6页｜第二种结果：允许区间内弯曲变化</a:t>
+            </a:r>
+          </a:p>
+          <a:p/>
+          <a:p>
+            <a:r>
+              <a:t>【操作提示】</a:t>
+            </a:r>
+          </a:p>
+          <a:p>
+            <a:r>
+              <a:t>指左侧起伏，再沿约1英亩以后的曲线向右说明走势。</a:t>
+            </a:r>
+          </a:p>
+          <a:p/>
+          <a:p>
+            <a:r>
+              <a:t>【上台讲稿】</a:t>
+            </a:r>
+          </a:p>
+          <a:p>
+            <a:r>
+              <a:t>第二种设定允许每个区间内使用二次曲线，并在连接处保持平滑，所以能够展示第一种方法没有表达的箱内变化。</a:t>
+            </a:r>
+          </a:p>
+          <a:p/>
+          <a:p>
+            <a:r>
+              <a:t>从图上看，小地块区域的曲线有升有降，并不是土地面积越大，拟合价值就始终越高。较大地块区域，约一英亩以后，拟合价值总体上升，而且在最后一个较宽的区间里仍然能够继续变化。</a:t>
+            </a:r>
+          </a:p>
+          <a:p/>
+          <a:p>
+            <a:r>
+              <a:t>这张图更平滑，但平滑是设定的性质，不能单凭这一点就说它一定更准确。图里没有画置信区间，我们也不判断每一次局部上升或下降是否统计显著。</a:t>
             </a:r>
           </a:p>
         </p:txBody>
@@ -1106,7 +1381,41 @@
           <a:lstStyle/>
           <a:p>
             <a:r>
-              <a:t>两种图使用相同样本、控制相同变量。这里用相同纵轴尺度并排看，避免原始单图自动坐标刻度影响视觉判断。左边是阶梯，右边可弯曲；较大地块区域总体正向，但细节与尾部走势受拟合设定影响。图中没有置信区间。</a:t>
+              <a:t>第7页｜比较：整体趋势相近，局部形状不同</a:t>
+            </a:r>
+          </a:p>
+          <a:p/>
+          <a:p>
+            <a:r>
+              <a:t>【操作提示】</a:t>
+            </a:r>
+          </a:p>
+          <a:p>
+            <a:r>
+              <a:t>指向并排的两张图，说明这一页使用相同纵轴尺度。</a:t>
+            </a:r>
+          </a:p>
+          <a:p/>
+          <a:p>
+            <a:r>
+              <a:t>【上台讲稿】</a:t>
+            </a:r>
+          </a:p>
+          <a:p>
+            <a:r>
+              <a:t>现在把两种结果放在一起比较。这一页使用相同的纵轴尺度，避免原来两张单图的自动刻度影响视觉判断。</a:t>
+            </a:r>
+          </a:p>
+          <a:p/>
+          <a:p>
+            <a:r>
+              <a:t>两种方法的共同点是：小地块区域有起伏，较大地块区域总体呈正向关系。因此，这种关系不适合简单概括为一条固定斜率的直线。</a:t>
+            </a:r>
+          </a:p>
+          <a:p/>
+          <a:p>
+            <a:r>
+              <a:t>区别在于第一种方法箱内保持水平，第二种允许箱内弯曲。特别是最后一个较宽的区间，两种方法呈现了不同走势。这说明局部形状和尾部走势会受到拟合设定影响。</a:t>
             </a:r>
           </a:p>
         </p:txBody>
@@ -1176,7 +1485,47 @@
           <a:lstStyle/>
           <a:p>
             <a:r>
-              <a:t>【收尾】我使用全部十万条记录，线性控制房间数，比较了老师要求的两种分箱回归。关系不是简单的一条直线，较大地块区域总体正向。控制房间数仍不能排除地段、房龄等其他因素，所以不作因果结论。下面交给下一位同学，在五间房样本中重复分析并讨论因果解释。</a:t>
+              <a:t>第8页｜本小问结论</a:t>
+            </a:r>
+          </a:p>
+          <a:p/>
+          <a:p>
+            <a:r>
+              <a:t>【操作提示】</a:t>
+            </a:r>
+          </a:p>
+          <a:p>
+            <a:r>
+              <a:t>依次指向三点结论，最后衔接下一位同学。</a:t>
+            </a:r>
+          </a:p>
+          <a:p/>
+          <a:p>
+            <a:r>
+              <a:t>【上台讲稿】</a:t>
+            </a:r>
+          </a:p>
+          <a:p>
+            <a:r>
+              <a:t>总结一下，我使用全部十万条记录，在线性控制房间数以后，比较了老师要求的两种分箱回归设定。</a:t>
+            </a:r>
+          </a:p>
+          <a:p/>
+          <a:p>
+            <a:r>
+              <a:t>结果显示，小地块区域有起伏，较大地块区域总体呈正向关系；但具体形状会随着拟合方式改变。</a:t>
+            </a:r>
+          </a:p>
+          <a:p/>
+          <a:p>
+            <a:r>
+              <a:t>最后，这里是控制房间数后的统计关系。地段、房龄等因素仍可能影响结果，因此不能直接说增加土地面积就会造成房屋价值上涨。</a:t>
+            </a:r>
+          </a:p>
+          <a:p/>
+          <a:p>
+            <a:r>
+              <a:t>下面交给下一位同学，在只保留五间房的样本中重复分析，并进一步讨论结果和因果解释。</a:t>
             </a:r>
           </a:p>
         </p:txBody>

</xml_diff>